<commit_message>
Support du Demo Day reconstruit : la comparaison des modeles sur la diapositive 14, le seuil 0,775 sur la 15
La diapositive du modele repond a la question du jury -- neuf candidats, memes plis ; regression logistique 0,812, SVM 0,807 a egalite, XGBoost 0,735, foret aleatoire 0,719, cout x 23 ; regle ecrite avant les resultats -- en lignes de la longueur de celles du gabarit d'origine. Trente decisions, 144 tests. Registre : R74 (choix de la famille de modele) et R75 (Model Card, diapositive et index perimes) ouverts et fermes ; R72 et R73 fermes, preuves a l'appui ; R66 a cinq outils sur sept.
</commit_message>
<xml_diff>
--- a/docs/presentation/ReviewPulse_DemoDay.pptx
+++ b/docs/presentation/ReviewPulse_DemoDay.pptx
@@ -8276,7 +8276,7 @@
                   <a:srgbClr val="FFFFFF"/>
                 </a:highlight>
               </a:rPr>
-              <a:t>→ retenu</a:t>
+              <a:t>→ retenu : robuste aux fautes, explicable</a:t>
             </a:r>
             <a:endParaRPr b="1" sz="1200">
               <a:solidFill>
@@ -8309,7 +8309,7 @@
                   <a:srgbClr val="FFFFFF"/>
                 </a:highlight>
               </a:rPr>
-              <a:t>Pourquoi les n-grammes de caractères ?</a:t>
+              <a:t>Un autre modèle ferait-il mieux ? 9 candidats, mêmes plis</a:t>
             </a:r>
             <a:endParaRPr b="1" sz="1200">
               <a:solidFill>
@@ -8347,7 +8347,7 @@
                   <a:srgbClr val="FFFFFF"/>
                 </a:highlight>
               </a:rPr>
-              <a:t>Robustes aux fautes et aux variantes d'écriture</a:t>
+              <a:t>Régression logistique 0,812 · SVM 0,807 : égalité</a:t>
             </a:r>
             <a:endParaRPr sz="1200">
               <a:solidFill>
@@ -8385,7 +8385,7 @@
                   <a:srgbClr val="FFFFFF"/>
                 </a:highlight>
               </a:rPr>
-              <a:t>Entraînement en quelques secondes, explicable terme par terme</a:t>
+              <a:t>XGBoost 0,735 · forêt aléatoire 0,719 · coût × 23</a:t>
             </a:r>
             <a:endParaRPr sz="1200">
               <a:solidFill>
@@ -8423,7 +8423,7 @@
                   <a:srgbClr val="FFFFFF"/>
                 </a:highlight>
               </a:rPr>
-              <a:t>Seuil de décision appris, et non fixé à 0,5 — ADR 0006, 0007</a:t>
+              <a:t>Règle écrite avant les résultats — ADR 0006, 0007, 0030</a:t>
             </a:r>
             <a:endParaRPr sz="1200">
               <a:solidFill>
@@ -8776,7 +8776,7 @@
                   <a:schemeClr val="dk2"/>
                 </a:solidFill>
               </a:rPr>
-              <a:t>0,75</a:t>
+              <a:t>0,775</a:t>
             </a:r>
             <a:r>
               <a:rPr lang="fr" sz="2400">
@@ -9746,7 +9746,7 @@
                   <a:srgbClr val="FFFFFF"/>
                 </a:highlight>
               </a:rPr>
-              <a:t>Socle de briques réemployables — 29 décisions écrites, ADR 0001 à 0029. Chaque bloc garde son projet imposé : ce sont les briques qui circulent, pas le projet</a:t>
+              <a:t>Socle de briques réemployables — 30 décisions écrites, ADR 0001 à 0030. Chaque bloc garde son projet imposé : ce sont les briques qui circulent, pas le projet</a:t>
             </a:r>
             <a:endParaRPr sz="1300">
               <a:solidFill>

</xml_diff>